<commit_message>
sanitize: update production domain and decouple school/personal identifiers
</commit_message>
<xml_diff>
--- a/public/briefings/ypres_2026_parent_briefing.pptx
+++ b/public/briefings/ypres_2026_parent_briefing.pptx
@@ -1145,7 +1145,7 @@
                 <a:ea typeface="Arial" pitchFamily="34" charset="-122"/>
                 <a:cs typeface="Arial" pitchFamily="34" charset="-120"/>
               </a:rPr>
-              <a:t>Meoncross School History Department &amp; The History Boys · Mr B. Lovett &amp; Mr J. Garrett (Leaders) · Accompanied by Two Meoncross Staff</a:t>
+              <a:t>The History Department &amp; The History Boys · Department Lead &amp; Mr J. Garrett (Leaders) · Accompanied by Fieldwork Staff</a:t>
             </a:r>
             <a:endParaRPr lang="en-US" sz="1050" dirty="0"/>
           </a:p>
@@ -1328,7 +1328,7 @@
                 <a:ea typeface="Arial" pitchFamily="34" charset="-122"/>
                 <a:cs typeface="Arial" pitchFamily="34" charset="-120"/>
               </a:rPr>
-              <a:t>• 06:15 departure from Meoncross School (Jet Connect).
+              <a:t>• 06:15 departure from The History Portal (Jet Connect).
 • 11:20 Eurotunnel; 14:30 Essex Farm ADS (Valentine Strudwick).
 • 15:15 Langemarck &amp; 16:00 Hooge Crater Museum.
 • 17:45 Peace Village, 18:15 dinner &amp; 19:15 classroom debrief.
@@ -2014,7 +2014,7 @@
       </p:sp>
       <p:pic>
         <p:nvPicPr>
-          <p:cNvPr id="19" name="Image 0" descr="C:\Projects\meoncross-history.netlify.app\public\images\tour_app_qr.png">    </p:cNvPr>
+          <p:cNvPr id="19" name="Image 0" descr="preencoded.png">    </p:cNvPr>
           <p:cNvPicPr>
             <a:picLocks noChangeAspect="1"/>
           </p:cNvPicPr>
@@ -2069,7 +2069,7 @@
                 <a:ea typeface="Arial" pitchFamily="34" charset="-122"/>
                 <a:cs typeface="Arial" pitchFamily="34" charset="-120"/>
               </a:rPr>
-              <a:t>INTERACTIVE DIGITAL FIELD GUIDE:  meoncross-history.netlify.app</a:t>
+              <a:t>INTERACTIVE DIGITAL FIELD GUIDE:  the-history-revision-hub.netlify.app</a:t>
             </a:r>
             <a:endParaRPr lang="en-US" sz="1000" dirty="0"/>
           </a:p>
@@ -2164,7 +2164,7 @@
                 <a:ea typeface="Arial" pitchFamily="34" charset="-122"/>
                 <a:cs typeface="Arial" pitchFamily="34" charset="-120"/>
               </a:rPr>
-              <a:t>School Base: 01329 662182</a:t>
+              <a:t>Fieldwork Support: 07825 297749</a:t>
             </a:r>
             <a:endParaRPr lang="en-US" sz="850" dirty="0"/>
           </a:p>
@@ -2294,7 +2294,7 @@
                 <a:ea typeface="Arial" pitchFamily="34" charset="-122"/>
                 <a:cs typeface="Arial" pitchFamily="34" charset="-120"/>
               </a:rPr>
-              <a:t>Preparation advice for autumn weather in the Flanders Salient · Meoncross History Department</a:t>
+              <a:t>Preparation advice for autumn weather in the Flanders Salient · The History Department</a:t>
             </a:r>
             <a:endParaRPr lang="en-US" sz="1000" dirty="0"/>
           </a:p>
@@ -2943,7 +2943,7 @@
                 <a:ea typeface="Arial" pitchFamily="34" charset="-122"/>
                 <a:cs typeface="Arial" pitchFamily="34" charset="-120"/>
               </a:rPr>
-              <a:t>Collected in advance tonight at briefing by Mr Lovett!
+              <a:t>Collected in advance tonight at briefing by Department Lead!
 </a:t>
             </a:r>
             <a:pPr indent="0" marL="0">
@@ -3939,7 +3939,7 @@
                 <a:ea typeface="Arial" pitchFamily="34" charset="-122"/>
                 <a:cs typeface="Arial" pitchFamily="34" charset="-120"/>
               </a:rPr>
-              <a:t>meoncross-history.netlify.app</a:t>
+              <a:t>the-history-revision-hub.netlify.app</a:t>
             </a:r>
             <a:endParaRPr lang="en-US" sz="950" dirty="0"/>
           </a:p>

</xml_diff>